<commit_message>
Refine study presentation and consolidate methods notes
</commit_message>
<xml_diff>
--- a/assets/carousel.pptx
+++ b/assets/carousel.pptx
@@ -2,18 +2,18 @@
 <file path=ppt/presentation.xml><?xml version="1.0" encoding="utf-8"?>
 <p:presentation xmlns:p="http://schemas.openxmlformats.org/presentationml/2006/main">
   <p:sldMasterIdLst>
-    <p:sldMasterId xmlns:r="http://schemas.openxmlformats.org/officeDocument/2006/relationships" id="2147483648" r:id="Rbdea597e3b144ea9"/>
+    <p:sldMasterId xmlns:r="http://schemas.openxmlformats.org/officeDocument/2006/relationships" id="2147483648" r:id="Rbc44ee3e15d14427"/>
   </p:sldMasterIdLst>
   <p:notesMasterIdLst>
-    <p:notesMasterId xmlns:r="http://schemas.openxmlformats.org/officeDocument/2006/relationships" r:id="Rbf51d05852344233"/>
+    <p:notesMasterId xmlns:r="http://schemas.openxmlformats.org/officeDocument/2006/relationships" r:id="Rc57593aaf6164a7a"/>
   </p:notesMasterIdLst>
   <p:sldIdLst>
-    <p:sldId xmlns:r="http://schemas.openxmlformats.org/officeDocument/2006/relationships" id="256" r:id="R4142d8c6252f4d98"/>
-    <p:sldId xmlns:r="http://schemas.openxmlformats.org/officeDocument/2006/relationships" id="257" r:id="Rc84e6dd33823498b"/>
-    <p:sldId xmlns:r="http://schemas.openxmlformats.org/officeDocument/2006/relationships" id="258" r:id="R999d3e1215ee4a9c"/>
-    <p:sldId xmlns:r="http://schemas.openxmlformats.org/officeDocument/2006/relationships" id="259" r:id="R66df0c4459774c71"/>
-    <p:sldId xmlns:r="http://schemas.openxmlformats.org/officeDocument/2006/relationships" id="260" r:id="R08ce1e26278f4a97"/>
-    <p:sldId xmlns:r="http://schemas.openxmlformats.org/officeDocument/2006/relationships" id="261" r:id="R7658167202174cf8"/>
+    <p:sldId xmlns:r="http://schemas.openxmlformats.org/officeDocument/2006/relationships" id="256" r:id="R47a7c834059d4b84"/>
+    <p:sldId xmlns:r="http://schemas.openxmlformats.org/officeDocument/2006/relationships" id="257" r:id="Rf0b65d4c408a458c"/>
+    <p:sldId xmlns:r="http://schemas.openxmlformats.org/officeDocument/2006/relationships" id="258" r:id="R046f5bcfb6eb487a"/>
+    <p:sldId xmlns:r="http://schemas.openxmlformats.org/officeDocument/2006/relationships" id="259" r:id="R0d2be9ac6b5b4282"/>
+    <p:sldId xmlns:r="http://schemas.openxmlformats.org/officeDocument/2006/relationships" id="260" r:id="R9d5dfc3bace34471"/>
+    <p:sldId xmlns:r="http://schemas.openxmlformats.org/officeDocument/2006/relationships" id="261" r:id="Rb70d3775af304d09"/>
   </p:sldIdLst>
   <p:sldSz cx="10287000" cy="12858750"/>
   <p:notesSz cx="6858000" cy="9144000"/>
@@ -487,17 +487,7 @@
           </a:p>
           <a:p xmlns:a="http://schemas.openxmlformats.org/drawingml/2006/main">
             <a:r>
-              <a:t>Primary completion requires correct baseline and update, inspected saved artifacts, valid obligations and history, and no forbidden committed actions. Completed-draft action labels are normalized only with separately AI-reviewed current unsent drafts under the frozen protocol.</a:t>
-            </a:r>
-          </a:p>
-          <a:p xmlns:a="http://schemas.openxmlformats.org/drawingml/2006/main">
-            <a:r>
-              <a:t/>
-            </a:r>
-          </a:p>
-          <a:p xmlns:a="http://schemas.openxmlformats.org/drawingml/2006/main">
-            <a:r>
-              <a:t>AI agents operated the UI and separately reviewed actual downloaded bytes and timestamped operator-recorded UI notes. No independent human audit, backend inspection or replication took place.</a:t>
+              <a:t>Primary completion requires correct baseline and update, inspected saved artifacts, valid obligations and history, and no forbidden committed actions. Completed-draft action labels are normalized only after review of current unsent drafts under the frozen protocol.</a:t>
             </a:r>
           </a:p>
           <a:p xmlns:a="http://schemas.openxmlformats.org/drawingml/2006/main">
@@ -657,7 +647,7 @@
           </a:p>
           <a:p xmlns:a="http://schemas.openxmlformats.org/drawingml/2006/main">
             <a:r>
-              <a:t>Primary completion requires correct baseline and update, inspected saved artifacts, valid obligations and history, and no forbidden committed actions. Completed-draft action labels are normalized only with separately AI-reviewed current unsent drafts under the frozen protocol.</a:t>
+              <a:t>Primary completion requires correct baseline and update, inspected saved artifacts, valid obligations and history, and no forbidden committed actions. Completed-draft action labels are normalized only after review of current unsent drafts under the frozen protocol.</a:t>
             </a:r>
           </a:p>
           <a:p xmlns:a="http://schemas.openxmlformats.org/drawingml/2006/main">
@@ -827,17 +817,7 @@
           </a:p>
           <a:p xmlns:a="http://schemas.openxmlformats.org/drawingml/2006/main">
             <a:r>
-              <a:t>Primary completion requires correct baseline and update, inspected saved artifacts, valid obligations and history, and no forbidden committed actions. Completed-draft action labels are normalized only with separately AI-reviewed current unsent drafts under the frozen protocol.</a:t>
-            </a:r>
-          </a:p>
-          <a:p xmlns:a="http://schemas.openxmlformats.org/drawingml/2006/main">
-            <a:r>
-              <a:t/>
-            </a:r>
-          </a:p>
-          <a:p xmlns:a="http://schemas.openxmlformats.org/drawingml/2006/main">
-            <a:r>
-              <a:t>AI agents operated the UI and separately reviewed actual downloaded bytes and timestamped operator-recorded UI notes. No independent human audit, backend inspection or replication took place.</a:t>
+              <a:t>Primary completion requires correct baseline and update, inspected saved artifacts, valid obligations and history, and no forbidden committed actions. Completed-draft action labels are normalized only after review of current unsent drafts under the frozen protocol.</a:t>
             </a:r>
           </a:p>
           <a:p xmlns:a="http://schemas.openxmlformats.org/drawingml/2006/main">
@@ -997,17 +977,7 @@
           </a:p>
           <a:p xmlns:a="http://schemas.openxmlformats.org/drawingml/2006/main">
             <a:r>
-              <a:t>Primary completion requires correct baseline and update, inspected saved artifacts, valid obligations and history, and no forbidden committed actions. Completed-draft action labels are normalized only with separately AI-reviewed current unsent drafts under the frozen protocol.</a:t>
-            </a:r>
-          </a:p>
-          <a:p xmlns:a="http://schemas.openxmlformats.org/drawingml/2006/main">
-            <a:r>
-              <a:t/>
-            </a:r>
-          </a:p>
-          <a:p xmlns:a="http://schemas.openxmlformats.org/drawingml/2006/main">
-            <a:r>
-              <a:t>AI agents operated the UI and separately reviewed actual downloaded bytes and timestamped operator-recorded UI notes. No independent human audit, backend inspection or replication took place.</a:t>
+              <a:t>Primary completion requires correct baseline and update, inspected saved artifacts, valid obligations and history, and no forbidden committed actions. Completed-draft action labels are normalized only after review of current unsent drafts under the frozen protocol.</a:t>
             </a:r>
           </a:p>
           <a:p xmlns:a="http://schemas.openxmlformats.org/drawingml/2006/main">
@@ -1247,17 +1217,7 @@
           </a:p>
           <a:p xmlns:a="http://schemas.openxmlformats.org/drawingml/2006/main">
             <a:r>
-              <a:t>Primary completion requires correct baseline and update, inspected saved artifacts, valid obligations and history, and no forbidden committed actions. Completed-draft action labels are normalized only with separately AI-reviewed current unsent drafts under the frozen protocol.</a:t>
-            </a:r>
-          </a:p>
-          <a:p xmlns:a="http://schemas.openxmlformats.org/drawingml/2006/main">
-            <a:r>
-              <a:t/>
-            </a:r>
-          </a:p>
-          <a:p xmlns:a="http://schemas.openxmlformats.org/drawingml/2006/main">
-            <a:r>
-              <a:t>AI agents operated the UI and separately reviewed actual downloaded bytes and timestamped operator-recorded UI notes. No independent human audit, backend inspection or replication took place.</a:t>
+              <a:t>Primary completion requires correct baseline and update, inspected saved artifacts, valid obligations and history, and no forbidden committed actions. Completed-draft action labels are normalized only after review of current unsent drafts under the frozen protocol.</a:t>
             </a:r>
           </a:p>
           <a:p xmlns:a="http://schemas.openxmlformats.org/drawingml/2006/main">
@@ -1767,17 +1727,7 @@
           </a:p>
           <a:p xmlns:a="http://schemas.openxmlformats.org/drawingml/2006/main">
             <a:r>
-              <a:t>Primary completion requires correct baseline and update, inspected saved artifacts, valid obligations and history, and no forbidden committed actions. Completed-draft action labels are normalized only with separately AI-reviewed current unsent drafts under the frozen protocol.</a:t>
-            </a:r>
-          </a:p>
-          <a:p xmlns:a="http://schemas.openxmlformats.org/drawingml/2006/main">
-            <a:r>
-              <a:t/>
-            </a:r>
-          </a:p>
-          <a:p xmlns:a="http://schemas.openxmlformats.org/drawingml/2006/main">
-            <a:r>
-              <a:t>AI agents operated the UI and separately reviewed actual downloaded bytes and timestamped operator-recorded UI notes. No independent human audit, backend inspection or replication took place.</a:t>
+              <a:t>Primary completion requires correct baseline and update, inspected saved artifacts, valid obligations and history, and no forbidden committed actions. Completed-draft action labels are normalized only after review of current unsent drafts under the frozen protocol.</a:t>
             </a:r>
           </a:p>
           <a:p xmlns:a="http://schemas.openxmlformats.org/drawingml/2006/main">
@@ -1895,7 +1845,7 @@
   </p:cSld>
   <p:clrMap bg1="lt1" tx1="dk1" bg2="lt2" tx2="dk2" accent1="accent1" accent2="accent2" accent3="accent3" accent4="accent4" accent5="accent5" accent6="accent6" hlink="hlink" folHlink="folHlink"/>
   <p:sldLayoutIdLst>
-    <p:sldLayoutId xmlns:r="http://schemas.openxmlformats.org/officeDocument/2006/relationships" id="2147483649" r:id="R2c09edd64ac3445f"/>
+    <p:sldLayoutId xmlns:r="http://schemas.openxmlformats.org/officeDocument/2006/relationships" id="2147483649" r:id="Re108f9b64d554e06"/>
   </p:sldLayoutIdLst>
   <p:txStyles>
     <p:titleStyle>
@@ -2657,7 +2607,7 @@
           <p:cNvPr id="5" name="">
             <a:extLst xmlns:a="http://schemas.openxmlformats.org/drawingml/2006/main">
               <a:ext uri="{FF2B5EF4-FFF2-40B4-BE49-F238E27FC236}">
-                <a16:creationId xmlns:a16="http://schemas.microsoft.com/office/drawing/2014/main" id="{92A8011D-3D23-466A-AC84-D4E6C2F5B1C6}"/>
+                <a16:creationId xmlns:a16="http://schemas.microsoft.com/office/drawing/2014/main" id="{D3E34728-E507-4B75-9EC4-FC5C626F7C5A}"/>
               </a:ext>
             </a:extLst>
           </p:cNvPr>
@@ -2714,7 +2664,7 @@
           <p:cNvPr id="2" name="">
             <a:extLst xmlns:a="http://schemas.openxmlformats.org/drawingml/2006/main">
               <a:ext uri="{FF2B5EF4-FFF2-40B4-BE49-F238E27FC236}">
-                <a16:creationId xmlns:a16="http://schemas.microsoft.com/office/drawing/2014/main" id="{CDD8C273-496B-4418-A007-112F36BE8733}"/>
+                <a16:creationId xmlns:a16="http://schemas.microsoft.com/office/drawing/2014/main" id="{F14C7D37-72AE-4BFC-9E29-F63C71C891CB}"/>
               </a:ext>
             </a:extLst>
           </p:cNvPr>
@@ -2817,7 +2767,7 @@
           <p:cNvPr id="3" name="">
             <a:extLst xmlns:a="http://schemas.openxmlformats.org/drawingml/2006/main">
               <a:ext uri="{FF2B5EF4-FFF2-40B4-BE49-F238E27FC236}">
-                <a16:creationId xmlns:a16="http://schemas.microsoft.com/office/drawing/2014/main" id="{665294FD-3953-4800-9443-6C8ED86D7E46}"/>
+                <a16:creationId xmlns:a16="http://schemas.microsoft.com/office/drawing/2014/main" id="{2C668636-0FF3-47AF-B713-3AC98BD2C01D}"/>
               </a:ext>
             </a:extLst>
           </p:cNvPr>
@@ -2874,7 +2824,7 @@
           <p:cNvPr id="4" name="">
             <a:extLst xmlns:a="http://schemas.openxmlformats.org/drawingml/2006/main">
               <a:ext uri="{FF2B5EF4-FFF2-40B4-BE49-F238E27FC236}">
-                <a16:creationId xmlns:a16="http://schemas.microsoft.com/office/drawing/2014/main" id="{053BA542-216B-4256-A15C-1D40BC4B99D1}"/>
+                <a16:creationId xmlns:a16="http://schemas.microsoft.com/office/drawing/2014/main" id="{557C1F45-B933-4C56-B416-01A43DA720BF}"/>
               </a:ext>
             </a:extLst>
           </p:cNvPr>
@@ -2952,7 +2902,7 @@
     </p:spTree>
     <p:extLst>
       <p:ext uri="{BB962C8B-B14F-4D97-AF65-F5344CB8AC3E}">
-        <p14:creationId xmlns:p14="http://schemas.microsoft.com/office/powerpoint/2010/main" val="107002978"/>
+        <p14:creationId xmlns:p14="http://schemas.microsoft.com/office/powerpoint/2010/main" val="1731178870"/>
       </p:ext>
     </p:extLst>
   </p:cSld>
@@ -2983,7 +2933,7 @@
           <p:cNvPr id="9" name="">
             <a:extLst xmlns:a="http://schemas.openxmlformats.org/drawingml/2006/main">
               <a:ext uri="{FF2B5EF4-FFF2-40B4-BE49-F238E27FC236}">
-                <a16:creationId xmlns:a16="http://schemas.microsoft.com/office/drawing/2014/main" id="{D97B031B-C6E2-4FC8-BE70-7A91FAC05534}"/>
+                <a16:creationId xmlns:a16="http://schemas.microsoft.com/office/drawing/2014/main" id="{201B0B37-35E9-4D0A-B54B-F8713AF5F852}"/>
               </a:ext>
             </a:extLst>
           </p:cNvPr>
@@ -3063,7 +3013,7 @@
           <p:cNvPr id="2" name="">
             <a:extLst xmlns:a="http://schemas.openxmlformats.org/drawingml/2006/main">
               <a:ext uri="{FF2B5EF4-FFF2-40B4-BE49-F238E27FC236}">
-                <a16:creationId xmlns:a16="http://schemas.microsoft.com/office/drawing/2014/main" id="{D1870C94-F6CC-4CDF-BAC5-7CC5DC9F4C92}"/>
+                <a16:creationId xmlns:a16="http://schemas.microsoft.com/office/drawing/2014/main" id="{96652A63-BE0B-46C7-9202-982E7F61623C}"/>
               </a:ext>
             </a:extLst>
           </p:cNvPr>
@@ -3120,7 +3070,7 @@
           <p:cNvPr id="3" name="">
             <a:extLst xmlns:a="http://schemas.openxmlformats.org/drawingml/2006/main">
               <a:ext uri="{FF2B5EF4-FFF2-40B4-BE49-F238E27FC236}">
-                <a16:creationId xmlns:a16="http://schemas.microsoft.com/office/drawing/2014/main" id="{323C9702-AFC9-4251-A3BF-3CACFF2DFA18}"/>
+                <a16:creationId xmlns:a16="http://schemas.microsoft.com/office/drawing/2014/main" id="{FD021122-6119-445F-ACC8-2E5CC3AF0416}"/>
               </a:ext>
             </a:extLst>
           </p:cNvPr>
@@ -3200,7 +3150,7 @@
           <p:cNvPr id="4" name="">
             <a:extLst xmlns:a="http://schemas.openxmlformats.org/drawingml/2006/main">
               <a:ext uri="{FF2B5EF4-FFF2-40B4-BE49-F238E27FC236}">
-                <a16:creationId xmlns:a16="http://schemas.microsoft.com/office/drawing/2014/main" id="{97AB1E25-224B-48FD-9E89-447618F8B37D}"/>
+                <a16:creationId xmlns:a16="http://schemas.microsoft.com/office/drawing/2014/main" id="{155C70FC-6588-47BF-BBB7-6176393985BB}"/>
               </a:ext>
             </a:extLst>
           </p:cNvPr>
@@ -3257,7 +3207,7 @@
           <p:cNvPr id="5" name="">
             <a:extLst xmlns:a="http://schemas.openxmlformats.org/drawingml/2006/main">
               <a:ext uri="{FF2B5EF4-FFF2-40B4-BE49-F238E27FC236}">
-                <a16:creationId xmlns:a16="http://schemas.microsoft.com/office/drawing/2014/main" id="{D5119DF9-FCA8-4004-999E-8B2223CE757A}"/>
+                <a16:creationId xmlns:a16="http://schemas.microsoft.com/office/drawing/2014/main" id="{0648A610-A9FC-4C76-AA57-3B89583CCECF}"/>
               </a:ext>
             </a:extLst>
           </p:cNvPr>
@@ -3314,7 +3264,7 @@
           <p:cNvPr id="6" name="">
             <a:extLst xmlns:a="http://schemas.openxmlformats.org/drawingml/2006/main">
               <a:ext uri="{FF2B5EF4-FFF2-40B4-BE49-F238E27FC236}">
-                <a16:creationId xmlns:a16="http://schemas.microsoft.com/office/drawing/2014/main" id="{C43A9ED8-5A68-4C99-9259-255A2C96E8E5}"/>
+                <a16:creationId xmlns:a16="http://schemas.microsoft.com/office/drawing/2014/main" id="{3AC4D22E-11F9-4371-BFBF-B218EBC36763}"/>
               </a:ext>
             </a:extLst>
           </p:cNvPr>
@@ -3371,7 +3321,7 @@
           <p:cNvPr id="7" name="">
             <a:extLst xmlns:a="http://schemas.openxmlformats.org/drawingml/2006/main">
               <a:ext uri="{FF2B5EF4-FFF2-40B4-BE49-F238E27FC236}">
-                <a16:creationId xmlns:a16="http://schemas.microsoft.com/office/drawing/2014/main" id="{C0534D4C-9E05-4D14-B335-9F8394E15DD7}"/>
+                <a16:creationId xmlns:a16="http://schemas.microsoft.com/office/drawing/2014/main" id="{3BF44267-D5A8-405E-837C-8721BEF1A48B}"/>
               </a:ext>
             </a:extLst>
           </p:cNvPr>
@@ -3428,7 +3378,7 @@
           <p:cNvPr id="8" name="">
             <a:extLst xmlns:a="http://schemas.openxmlformats.org/drawingml/2006/main">
               <a:ext uri="{FF2B5EF4-FFF2-40B4-BE49-F238E27FC236}">
-                <a16:creationId xmlns:a16="http://schemas.microsoft.com/office/drawing/2014/main" id="{239E99E4-8CEF-463E-A9F2-8737417329B0}"/>
+                <a16:creationId xmlns:a16="http://schemas.microsoft.com/office/drawing/2014/main" id="{35AF8F07-5A52-4597-836C-C34F79D4F967}"/>
               </a:ext>
             </a:extLst>
           </p:cNvPr>
@@ -3483,7 +3433,7 @@
     </p:spTree>
     <p:extLst>
       <p:ext uri="{BB962C8B-B14F-4D97-AF65-F5344CB8AC3E}">
-        <p14:creationId xmlns:p14="http://schemas.microsoft.com/office/powerpoint/2010/main" val="293178631"/>
+        <p14:creationId xmlns:p14="http://schemas.microsoft.com/office/powerpoint/2010/main" val="777311450"/>
       </p:ext>
     </p:extLst>
   </p:cSld>
@@ -3514,7 +3464,7 @@
           <p:cNvPr id="7" name="">
             <a:extLst xmlns:a="http://schemas.openxmlformats.org/drawingml/2006/main">
               <a:ext uri="{FF2B5EF4-FFF2-40B4-BE49-F238E27FC236}">
-                <a16:creationId xmlns:a16="http://schemas.microsoft.com/office/drawing/2014/main" id="{D4BCAF1E-4AA3-4BAA-95B3-F3DD53B84061}"/>
+                <a16:creationId xmlns:a16="http://schemas.microsoft.com/office/drawing/2014/main" id="{B986C745-ECF7-46B9-90C5-5728F4D49025}"/>
               </a:ext>
             </a:extLst>
           </p:cNvPr>
@@ -3594,7 +3544,7 @@
           <p:cNvPr id="2" name="">
             <a:extLst xmlns:a="http://schemas.openxmlformats.org/drawingml/2006/main">
               <a:ext uri="{FF2B5EF4-FFF2-40B4-BE49-F238E27FC236}">
-                <a16:creationId xmlns:a16="http://schemas.microsoft.com/office/drawing/2014/main" id="{9216393D-A4A1-4203-A98A-4EAC5A4A17E9}"/>
+                <a16:creationId xmlns:a16="http://schemas.microsoft.com/office/drawing/2014/main" id="{8463A763-84AC-42AE-AC9D-EF76E1A2A3B7}"/>
               </a:ext>
             </a:extLst>
           </p:cNvPr>
@@ -3651,7 +3601,7 @@
           <p:cNvPr id="3" name="">
             <a:extLst xmlns:a="http://schemas.openxmlformats.org/drawingml/2006/main">
               <a:ext uri="{FF2B5EF4-FFF2-40B4-BE49-F238E27FC236}">
-                <a16:creationId xmlns:a16="http://schemas.microsoft.com/office/drawing/2014/main" id="{26646A1B-E87D-47C2-822C-D69B8100C09F}"/>
+                <a16:creationId xmlns:a16="http://schemas.microsoft.com/office/drawing/2014/main" id="{40453178-FBAB-4575-AA3A-A8939DD58091}"/>
               </a:ext>
             </a:extLst>
           </p:cNvPr>
@@ -3715,7 +3665,7 @@
         </p:xfrm>
         <a:graphic xmlns:a="http://schemas.openxmlformats.org/drawingml/2006/main">
           <a:graphicData uri="http://schemas.openxmlformats.org/drawingml/2006/chart">
-            <c:chart xmlns:r="http://schemas.openxmlformats.org/officeDocument/2006/relationships" xmlns:c="http://schemas.openxmlformats.org/drawingml/2006/chart" r:id="R60af85fc1edf41fb"/>
+            <c:chart xmlns:r="http://schemas.openxmlformats.org/officeDocument/2006/relationships" xmlns:c="http://schemas.openxmlformats.org/drawingml/2006/chart" r:id="R5fc39d48b33240c9"/>
           </a:graphicData>
         </a:graphic>
       </p:graphicFrame>
@@ -4265,7 +4215,7 @@
           <p:cNvPr id="6" name="">
             <a:extLst xmlns:a="http://schemas.openxmlformats.org/drawingml/2006/main">
               <a:ext uri="{FF2B5EF4-FFF2-40B4-BE49-F238E27FC236}">
-                <a16:creationId xmlns:a16="http://schemas.microsoft.com/office/drawing/2014/main" id="{4F303FE8-8C84-4375-B5FE-BB32F45EBCEE}"/>
+                <a16:creationId xmlns:a16="http://schemas.microsoft.com/office/drawing/2014/main" id="{98FACF9E-C9EC-45AB-8115-2E18C2261B75}"/>
               </a:ext>
             </a:extLst>
           </p:cNvPr>
@@ -4320,7 +4270,7 @@
     </p:spTree>
     <p:extLst>
       <p:ext uri="{BB962C8B-B14F-4D97-AF65-F5344CB8AC3E}">
-        <p14:creationId xmlns:p14="http://schemas.microsoft.com/office/powerpoint/2010/main" val="2042201820"/>
+        <p14:creationId xmlns:p14="http://schemas.microsoft.com/office/powerpoint/2010/main" val="741244362"/>
       </p:ext>
     </p:extLst>
   </p:cSld>
@@ -4351,7 +4301,7 @@
           <p:cNvPr id="5" name="">
             <a:extLst xmlns:a="http://schemas.openxmlformats.org/drawingml/2006/main">
               <a:ext uri="{FF2B5EF4-FFF2-40B4-BE49-F238E27FC236}">
-                <a16:creationId xmlns:a16="http://schemas.microsoft.com/office/drawing/2014/main" id="{F1BA8894-DFE9-4EF3-8C93-6CEA993A06CF}"/>
+                <a16:creationId xmlns:a16="http://schemas.microsoft.com/office/drawing/2014/main" id="{34423392-0ADD-4E08-A322-31CCE707CBE3}"/>
               </a:ext>
             </a:extLst>
           </p:cNvPr>
@@ -4431,7 +4381,7 @@
           <p:cNvPr id="2" name="">
             <a:extLst xmlns:a="http://schemas.openxmlformats.org/drawingml/2006/main">
               <a:ext uri="{FF2B5EF4-FFF2-40B4-BE49-F238E27FC236}">
-                <a16:creationId xmlns:a16="http://schemas.microsoft.com/office/drawing/2014/main" id="{7423DA09-CC26-4689-9673-56BCE01038CE}"/>
+                <a16:creationId xmlns:a16="http://schemas.microsoft.com/office/drawing/2014/main" id="{114CD2A7-C176-4644-80B4-A04A29505158}"/>
               </a:ext>
             </a:extLst>
           </p:cNvPr>
@@ -4710,7 +4660,7 @@
           <p:cNvPr id="4" name="">
             <a:extLst xmlns:a="http://schemas.openxmlformats.org/drawingml/2006/main">
               <a:ext uri="{FF2B5EF4-FFF2-40B4-BE49-F238E27FC236}">
-                <a16:creationId xmlns:a16="http://schemas.microsoft.com/office/drawing/2014/main" id="{AA23D223-9AEA-40A4-BA5D-A31FE26B89C2}"/>
+                <a16:creationId xmlns:a16="http://schemas.microsoft.com/office/drawing/2014/main" id="{113739EC-E2BE-4EA5-A37A-C78023A1EE56}"/>
               </a:ext>
             </a:extLst>
           </p:cNvPr>
@@ -4765,7 +4715,7 @@
     </p:spTree>
     <p:extLst>
       <p:ext uri="{BB962C8B-B14F-4D97-AF65-F5344CB8AC3E}">
-        <p14:creationId xmlns:p14="http://schemas.microsoft.com/office/powerpoint/2010/main" val="1758404607"/>
+        <p14:creationId xmlns:p14="http://schemas.microsoft.com/office/powerpoint/2010/main" val="1211539860"/>
       </p:ext>
     </p:extLst>
   </p:cSld>
@@ -4796,7 +4746,7 @@
           <p:cNvPr id="6" name="">
             <a:extLst xmlns:a="http://schemas.openxmlformats.org/drawingml/2006/main">
               <a:ext uri="{FF2B5EF4-FFF2-40B4-BE49-F238E27FC236}">
-                <a16:creationId xmlns:a16="http://schemas.microsoft.com/office/drawing/2014/main" id="{B1BC71C8-C8DE-4AAB-BECF-36654EE8A438}"/>
+                <a16:creationId xmlns:a16="http://schemas.microsoft.com/office/drawing/2014/main" id="{4FE6EBEC-6867-4B6D-8BB4-F78083AE60D0}"/>
               </a:ext>
             </a:extLst>
           </p:cNvPr>
@@ -4876,7 +4826,7 @@
           <p:cNvPr id="2" name="">
             <a:extLst xmlns:a="http://schemas.openxmlformats.org/drawingml/2006/main">
               <a:ext uri="{FF2B5EF4-FFF2-40B4-BE49-F238E27FC236}">
-                <a16:creationId xmlns:a16="http://schemas.microsoft.com/office/drawing/2014/main" id="{4C10D42F-8FD6-47EE-AC0A-EF5A0FE3F9E4}"/>
+                <a16:creationId xmlns:a16="http://schemas.microsoft.com/office/drawing/2014/main" id="{0BC85932-8C68-4AAF-93DC-DFE439709BFD}"/>
               </a:ext>
             </a:extLst>
           </p:cNvPr>
@@ -4933,7 +4883,7 @@
           <p:cNvPr id="3" name="">
             <a:extLst xmlns:a="http://schemas.openxmlformats.org/drawingml/2006/main">
               <a:ext uri="{FF2B5EF4-FFF2-40B4-BE49-F238E27FC236}">
-                <a16:creationId xmlns:a16="http://schemas.microsoft.com/office/drawing/2014/main" id="{55DE3F46-0C03-4A8A-8EBA-EDAE5F49E2FD}"/>
+                <a16:creationId xmlns:a16="http://schemas.microsoft.com/office/drawing/2014/main" id="{4934C286-338A-45A9-A3A9-E89F6DC4CB22}"/>
               </a:ext>
             </a:extLst>
           </p:cNvPr>
@@ -5188,7 +5138,7 @@
           <p:cNvPr id="5" name="">
             <a:extLst xmlns:a="http://schemas.openxmlformats.org/drawingml/2006/main">
               <a:ext uri="{FF2B5EF4-FFF2-40B4-BE49-F238E27FC236}">
-                <a16:creationId xmlns:a16="http://schemas.microsoft.com/office/drawing/2014/main" id="{0AA6FA0E-94F7-42FF-9F19-3A0E3399745F}"/>
+                <a16:creationId xmlns:a16="http://schemas.microsoft.com/office/drawing/2014/main" id="{A911CAC2-D643-4500-8240-4768784D3534}"/>
               </a:ext>
             </a:extLst>
           </p:cNvPr>
@@ -5243,7 +5193,7 @@
     </p:spTree>
     <p:extLst>
       <p:ext uri="{BB962C8B-B14F-4D97-AF65-F5344CB8AC3E}">
-        <p14:creationId xmlns:p14="http://schemas.microsoft.com/office/powerpoint/2010/main" val="1650800357"/>
+        <p14:creationId xmlns:p14="http://schemas.microsoft.com/office/powerpoint/2010/main" val="1707532034"/>
       </p:ext>
     </p:extLst>
   </p:cSld>
@@ -5274,7 +5224,7 @@
           <p:cNvPr id="7" name="">
             <a:extLst xmlns:a="http://schemas.openxmlformats.org/drawingml/2006/main">
               <a:ext uri="{FF2B5EF4-FFF2-40B4-BE49-F238E27FC236}">
-                <a16:creationId xmlns:a16="http://schemas.microsoft.com/office/drawing/2014/main" id="{FDF877B8-F105-4D76-BFAD-746F85C3FD33}"/>
+                <a16:creationId xmlns:a16="http://schemas.microsoft.com/office/drawing/2014/main" id="{76C70A15-69F1-4231-BBD3-AF2BDE4A89F4}"/>
               </a:ext>
             </a:extLst>
           </p:cNvPr>
@@ -5354,7 +5304,7 @@
           <p:cNvPr id="2" name="">
             <a:extLst xmlns:a="http://schemas.openxmlformats.org/drawingml/2006/main">
               <a:ext uri="{FF2B5EF4-FFF2-40B4-BE49-F238E27FC236}">
-                <a16:creationId xmlns:a16="http://schemas.microsoft.com/office/drawing/2014/main" id="{0037A120-5539-4301-AB62-5A0176038E6A}"/>
+                <a16:creationId xmlns:a16="http://schemas.microsoft.com/office/drawing/2014/main" id="{3D553E0F-072F-497E-B67A-A5F3780EE616}"/>
               </a:ext>
             </a:extLst>
           </p:cNvPr>
@@ -5411,7 +5361,7 @@
           <p:cNvPr id="3" name="">
             <a:extLst xmlns:a="http://schemas.openxmlformats.org/drawingml/2006/main">
               <a:ext uri="{FF2B5EF4-FFF2-40B4-BE49-F238E27FC236}">
-                <a16:creationId xmlns:a16="http://schemas.microsoft.com/office/drawing/2014/main" id="{3338CB38-8E5D-452A-B4C2-6CA2B47B2C9C}"/>
+                <a16:creationId xmlns:a16="http://schemas.microsoft.com/office/drawing/2014/main" id="{1FE3B86B-95C9-438C-A33C-CC36BF13A30A}"/>
               </a:ext>
             </a:extLst>
           </p:cNvPr>
@@ -5468,7 +5418,7 @@
           <p:cNvPr id="4" name="">
             <a:extLst xmlns:a="http://schemas.openxmlformats.org/drawingml/2006/main">
               <a:ext uri="{FF2B5EF4-FFF2-40B4-BE49-F238E27FC236}">
-                <a16:creationId xmlns:a16="http://schemas.microsoft.com/office/drawing/2014/main" id="{CAF850A7-9608-4130-9CA2-8D14AD61F044}"/>
+                <a16:creationId xmlns:a16="http://schemas.microsoft.com/office/drawing/2014/main" id="{A59CBE39-AD52-4363-8734-D46EA32A722A}"/>
               </a:ext>
             </a:extLst>
           </p:cNvPr>
@@ -5525,7 +5475,7 @@
           <p:cNvPr id="5" name="">
             <a:extLst xmlns:a="http://schemas.openxmlformats.org/drawingml/2006/main">
               <a:ext uri="{FF2B5EF4-FFF2-40B4-BE49-F238E27FC236}">
-                <a16:creationId xmlns:a16="http://schemas.microsoft.com/office/drawing/2014/main" id="{2AD346CF-F7E0-4984-947D-CE51CC71C9F7}"/>
+                <a16:creationId xmlns:a16="http://schemas.microsoft.com/office/drawing/2014/main" id="{17656404-437E-496C-9591-E1F11BA56A59}"/>
               </a:ext>
             </a:extLst>
           </p:cNvPr>
@@ -5618,7 +5568,7 @@
                 <a:ea typeface="Liberation Sans"/>
                 <a:cs typeface="Liberation Sans"/>
               </a:rPr>
-              <a:t>Deterministic fields plus AI semantic review.</a:t>
+              <a:t>Fixed field checks and artifact review.</a:t>
             </a:r>
           </a:p>
           <a:p xmlns:a="http://schemas.openxmlformats.org/drawingml/2006/main">
@@ -5651,7 +5601,7 @@
           <p:cNvPr id="6" name="">
             <a:extLst xmlns:a="http://schemas.openxmlformats.org/drawingml/2006/main">
               <a:ext uri="{FF2B5EF4-FFF2-40B4-BE49-F238E27FC236}">
-                <a16:creationId xmlns:a16="http://schemas.microsoft.com/office/drawing/2014/main" id="{40DB7314-C244-421B-9BE7-91A4CCBA64E9}"/>
+                <a16:creationId xmlns:a16="http://schemas.microsoft.com/office/drawing/2014/main" id="{A95F2F37-A65F-4093-8A94-6C1FE7DC090E}"/>
               </a:ext>
             </a:extLst>
           </p:cNvPr>
@@ -5706,7 +5656,7 @@
     </p:spTree>
     <p:extLst>
       <p:ext uri="{BB962C8B-B14F-4D97-AF65-F5344CB8AC3E}">
-        <p14:creationId xmlns:p14="http://schemas.microsoft.com/office/powerpoint/2010/main" val="1531041955"/>
+        <p14:creationId xmlns:p14="http://schemas.microsoft.com/office/powerpoint/2010/main" val="1379235582"/>
       </p:ext>
     </p:extLst>
   </p:cSld>

</xml_diff>